<commit_message>
Convert video materials into narrated classes
</commit_message>
<xml_diff>
--- a/materiales/materiales_por_video/serie_60_videos/pptx_por_video/video-01.pptx
+++ b/materiales/materiales_por_video/serie_60_videos/pptx_por_video/video-01.pptx
@@ -8,6 +8,7 @@
     <p:sldId id="256" r:id="rId7"/>
     <p:sldId id="257" r:id="rId8"/>
     <p:sldId id="258" r:id="rId9"/>
+    <p:sldId id="259" r:id="rId10"/>
   </p:sldIdLst>
   <p:sldSz cx="12191695" cy="6858000" type="screen4x3"/>
   <p:notesSz cx="6858000" cy="9144000"/>
@@ -3636,54 +3637,6 @@
               <a:t>Resumen del tema</a:t>
             </a:r>
           </a:p>
-          <a:p>
-            <a:pPr>
-              <a:spcAft>
-                <a:spcPts val="400"/>
-              </a:spcAft>
-              <a:defRPr sz="1200" b="0">
-                <a:solidFill>
-                  <a:srgbClr val="1C2734"/>
-                </a:solidFill>
-                <a:latin typeface="Aptos"/>
-              </a:defRPr>
-            </a:pPr>
-            <a:r>
-              <a:t>Este video estudia decisiones de arquitectura y consecuencias reales con el objetivo de convertir una necesidad del negocio en una decisión arquitectónica explícita y verificable.</a:t>
-            </a:r>
-          </a:p>
-          <a:p>
-            <a:pPr>
-              <a:spcAft>
-                <a:spcPts val="400"/>
-              </a:spcAft>
-              <a:defRPr sz="1200">
-                <a:solidFill>
-                  <a:srgbClr val="1C2734"/>
-                </a:solidFill>
-                <a:latin typeface="Aptos"/>
-              </a:defRPr>
-            </a:pPr>
-            <a:r>
-              <a:t>El tema se conecta con el proyecto de la plataforma logística porque la plataforma logística debe recibir pedidos, asignar rutas y responder ante retrasos sin perder trazabilidad.</a:t>
-            </a:r>
-          </a:p>
-          <a:p>
-            <a:pPr>
-              <a:spcAft>
-                <a:spcPts val="400"/>
-              </a:spcAft>
-              <a:defRPr sz="1300">
-                <a:solidFill>
-                  <a:srgbClr val="1C2734"/>
-                </a:solidFill>
-                <a:latin typeface="Aptos"/>
-              </a:defRPr>
-            </a:pPr>
-            <a:r>
-              <a:t>La discusión no se limita a nombrar un patrón o una herramie</a:t>
-            </a:r>
-          </a:p>
         </p:txBody>
       </p:sp>
     </p:spTree>
@@ -4191,55 +4144,7 @@
               </a:defRPr>
             </a:pPr>
             <a:r>
-              <a:t>• La decisión debe partir del problema, los usuarios y las restricciones, no de una tecnología preferida.</a:t>
-            </a:r>
-          </a:p>
-          <a:p>
-            <a:pPr>
-              <a:spcAft>
-                <a:spcPts val="500"/>
-              </a:spcAft>
-              <a:defRPr sz="1200">
-                <a:solidFill>
-                  <a:srgbClr val="1C2734"/>
-                </a:solidFill>
-                <a:latin typeface="Aptos"/>
-              </a:defRPr>
-            </a:pPr>
-            <a:r>
-              <a:t>• Cada alternativa debe compararse por valor, costo, riesgo y capacidad de evolución.</a:t>
-            </a:r>
-          </a:p>
-          <a:p>
-            <a:pPr>
-              <a:spcAft>
-                <a:spcPts val="500"/>
-              </a:spcAft>
-              <a:defRPr sz="1200">
-                <a:solidFill>
-                  <a:srgbClr val="1C2734"/>
-                </a:solidFill>
-                <a:latin typeface="Aptos"/>
-              </a:defRPr>
-            </a:pPr>
-            <a:r>
-              <a:t>• Los supuestos deben quedar escritos para poder validarlos con evidencia.</a:t>
-            </a:r>
-          </a:p>
-          <a:p>
-            <a:pPr>
-              <a:spcAft>
-                <a:spcPts val="500"/>
-              </a:spcAft>
-              <a:defRPr sz="1200">
-                <a:solidFill>
-                  <a:srgbClr val="1C2734"/>
-                </a:solidFill>
-                <a:latin typeface="Aptos"/>
-              </a:defRPr>
-            </a:pPr>
-            <a:r>
-              <a:t>• El ejemplo debe documentarse junto con sus supuestos, trade-offs y evidencia de validación.</a:t>
+              <a:t>• </a:t>
             </a:r>
           </a:p>
         </p:txBody>
@@ -4328,16 +4233,13 @@
               <a:spcAft>
                 <a:spcPts val="400"/>
               </a:spcAft>
-              <a:defRPr sz="1200" b="0">
+              <a:defRPr sz="1300" b="0">
                 <a:solidFill>
                   <a:srgbClr val="1C2734"/>
                 </a:solidFill>
                 <a:latin typeface="Aptos"/>
               </a:defRPr>
             </a:pPr>
-            <a:r>
-              <a:t>Este video estudia decisiones de arquitectura y consecuencias reales con el objetivo de convertir una necesidad del negocio en una decisión arquitectónica explícita y verificable. </a:t>
-            </a:r>
           </a:p>
         </p:txBody>
       </p:sp>
@@ -4598,7 +4500,7 @@
               </a:defRPr>
             </a:pPr>
             <a:r>
-              <a:t>Conclusión y reflexión</a:t>
+              <a:t>Clase en acción</a:t>
             </a:r>
           </a:p>
         </p:txBody>
@@ -4749,7 +4651,7 @@
               </a:defRPr>
             </a:pPr>
             <a:r>
-              <a:t>VIDEO 01  /  03 / 03</a:t>
+              <a:t>VIDEO 01  /  03 / 04</a:t>
             </a:r>
           </a:p>
         </p:txBody>
@@ -4762,8 +4664,8 @@
         </p:nvSpPr>
         <p:spPr>
           <a:xfrm>
-            <a:off x="640080" y="1417320"/>
-            <a:ext cx="5577840" cy="4434840"/>
+            <a:off x="594360" y="1325880"/>
+            <a:ext cx="11018520" cy="1234440"/>
           </a:xfrm>
           <a:prstGeom prst="roundRect">
             <a:avLst/>
@@ -4807,8 +4709,8 @@
         </p:nvSpPr>
         <p:spPr>
           <a:xfrm>
-            <a:off x="804671" y="1527048"/>
-            <a:ext cx="5257800" cy="4297679"/>
+            <a:off x="758952" y="1435607"/>
+            <a:ext cx="10698480" cy="1097280"/>
           </a:xfrm>
           <a:prstGeom prst="rect">
             <a:avLst/>
@@ -4830,7 +4732,7 @@
               </a:defRPr>
             </a:pPr>
             <a:r>
-              <a:t>Conclusión</a:t>
+              <a:t>Propósito de aprendizaje</a:t>
             </a:r>
           </a:p>
           <a:p>
@@ -4846,7 +4748,104 @@
               </a:defRPr>
             </a:pPr>
             <a:r>
-              <a:t>Decisiones de arquitectura y consecuencias reales aporta una forma concreta de trabajar sobre la arquitectura del sistema.</a:t>
+              <a:t>Al finalizar la clase, el estudiante podrá convertir una necesidad del negocio en una decisión arquitectónica explícita y verificable y explicarlo usando el caso de la plataforma logística de última milla.</a:t>
+            </a:r>
+          </a:p>
+        </p:txBody>
+      </p:sp>
+      <p:sp>
+        <p:nvSpPr>
+          <p:cNvPr id="14" name="Rounded Rectangle 13"/>
+          <p:cNvSpPr/>
+          <p:nvPr/>
+        </p:nvSpPr>
+        <p:spPr>
+          <a:xfrm>
+            <a:off x="594360" y="2743200"/>
+            <a:ext cx="5394960" cy="2971800"/>
+          </a:xfrm>
+          <a:prstGeom prst="roundRect">
+            <a:avLst/>
+          </a:prstGeom>
+          <a:solidFill>
+            <a:srgbClr val="FFFFFF"/>
+          </a:solidFill>
+          <a:ln w="1">
+            <a:solidFill>
+              <a:srgbClr val="D2DBE3"/>
+            </a:solidFill>
+          </a:ln>
+        </p:spPr>
+        <p:style>
+          <a:lnRef idx="1">
+            <a:schemeClr val="accent1"/>
+          </a:lnRef>
+          <a:fillRef idx="3">
+            <a:schemeClr val="accent1"/>
+          </a:fillRef>
+          <a:effectRef idx="2">
+            <a:schemeClr val="accent1"/>
+          </a:effectRef>
+          <a:fontRef idx="minor">
+            <a:schemeClr val="lt1"/>
+          </a:fontRef>
+        </p:style>
+        <p:txBody>
+          <a:bodyPr rtlCol="0" anchor="ctr"/>
+          <a:lstStyle/>
+          <a:p>
+            <a:pPr algn="ctr"/>
+          </a:p>
+        </p:txBody>
+      </p:sp>
+      <p:sp>
+        <p:nvSpPr>
+          <p:cNvPr id="15" name="TextBox 14"/>
+          <p:cNvSpPr txBox="1"/>
+          <p:nvPr/>
+        </p:nvSpPr>
+        <p:spPr>
+          <a:xfrm>
+            <a:off x="758952" y="2852928"/>
+            <a:ext cx="5074920" cy="2834640"/>
+          </a:xfrm>
+          <a:prstGeom prst="rect">
+            <a:avLst/>
+          </a:prstGeom>
+          <a:noFill/>
+        </p:spPr>
+        <p:txBody>
+          <a:bodyPr wrap="square" lIns="36576" rIns="36576" tIns="18288" anchor="t">
+            <a:spAutoFit/>
+          </a:bodyPr>
+          <a:lstStyle/>
+          <a:p>
+            <a:pPr>
+              <a:defRPr b="1" sz="1400">
+                <a:solidFill>
+                  <a:srgbClr val="E0B24C"/>
+                </a:solidFill>
+                <a:latin typeface="Aptos Display"/>
+              </a:defRPr>
+            </a:pPr>
+            <a:r>
+              <a:t>Apertura y explicación</a:t>
+            </a:r>
+          </a:p>
+          <a:p>
+            <a:pPr>
+              <a:spcAft>
+                <a:spcPts val="400"/>
+              </a:spcAft>
+              <a:defRPr sz="1200" b="0">
+                <a:solidFill>
+                  <a:srgbClr val="1C2734"/>
+                </a:solidFill>
+                <a:latin typeface="Aptos"/>
+              </a:defRPr>
+            </a:pPr>
+            <a:r>
+              <a:t>Comenzar con esta situación: la plataforma logística debe recibir pedidos, asignar rutas y responder ante retrasos sin perder trazabilidad. Pedir a los estudiantes que respondan qué podría fallar, quién se vería afectado y qué decisión técnica tendría mayor impacto. No iniciar con nombres de patrones; iniciar con el problema y las consecuencias observables.</a:t>
             </a:r>
           </a:p>
           <a:p>
@@ -4862,7 +4861,93 @@
               </a:defRPr>
             </a:pPr>
             <a:r>
-              <a:t>Su valor aparece cuando conecta el contexto del negocio con una estructura implementable, medible y capaz de evolucionar.</a:t>
+              <a:t>El docente presenta decisiones de arquitectura y consecuencias reales como una decisión situada. Primero delimita el problema y sus actores; después muestra qué alternativas existen; finalmente relaciona cada alternativa con costo, riesgo y calidad. La pregunta que guía la clase es: ¿qué evidencia permitiría defender esta decisión ante el equipo y el negocio?</a:t>
+            </a:r>
+            <a:br/>
+            <a:br/>
+            <a:r>
+              <a:t>El concepto se trabaja en tres movimientos. Primero, se describe el contexto y se separ</a:t>
+            </a:r>
+          </a:p>
+        </p:txBody>
+      </p:sp>
+      <p:sp>
+        <p:nvSpPr>
+          <p:cNvPr id="16" name="Rounded Rectangle 15"/>
+          <p:cNvSpPr/>
+          <p:nvPr/>
+        </p:nvSpPr>
+        <p:spPr>
+          <a:xfrm>
+            <a:off x="6217920" y="2743200"/>
+            <a:ext cx="5394960" cy="2971800"/>
+          </a:xfrm>
+          <a:prstGeom prst="roundRect">
+            <a:avLst/>
+          </a:prstGeom>
+          <a:solidFill>
+            <a:srgbClr val="FFFFFF"/>
+          </a:solidFill>
+          <a:ln w="1">
+            <a:solidFill>
+              <a:srgbClr val="D2DBE3"/>
+            </a:solidFill>
+          </a:ln>
+        </p:spPr>
+        <p:style>
+          <a:lnRef idx="1">
+            <a:schemeClr val="accent1"/>
+          </a:lnRef>
+          <a:fillRef idx="3">
+            <a:schemeClr val="accent1"/>
+          </a:fillRef>
+          <a:effectRef idx="2">
+            <a:schemeClr val="accent1"/>
+          </a:effectRef>
+          <a:fontRef idx="minor">
+            <a:schemeClr val="lt1"/>
+          </a:fontRef>
+        </p:style>
+        <p:txBody>
+          <a:bodyPr rtlCol="0" anchor="ctr"/>
+          <a:lstStyle/>
+          <a:p>
+            <a:pPr algn="ctr"/>
+          </a:p>
+        </p:txBody>
+      </p:sp>
+      <p:sp>
+        <p:nvSpPr>
+          <p:cNvPr id="17" name="TextBox 16"/>
+          <p:cNvSpPr txBox="1"/>
+          <p:nvPr/>
+        </p:nvSpPr>
+        <p:spPr>
+          <a:xfrm>
+            <a:off x="6382512" y="2852928"/>
+            <a:ext cx="5074920" cy="2834640"/>
+          </a:xfrm>
+          <a:prstGeom prst="rect">
+            <a:avLst/>
+          </a:prstGeom>
+          <a:noFill/>
+        </p:spPr>
+        <p:txBody>
+          <a:bodyPr wrap="square" lIns="36576" rIns="36576" tIns="18288" anchor="t">
+            <a:spAutoFit/>
+          </a:bodyPr>
+          <a:lstStyle/>
+          <a:p>
+            <a:pPr>
+              <a:defRPr b="1" sz="1400">
+                <a:solidFill>
+                  <a:srgbClr val="239391"/>
+                </a:solidFill>
+                <a:latin typeface="Aptos Display"/>
+              </a:defRPr>
+            </a:pPr>
+            <a:r>
+              <a:t>Práctica guiada</a:t>
             </a:r>
           </a:p>
           <a:p>
@@ -4870,7 +4955,7 @@
               <a:spcAft>
                 <a:spcPts val="400"/>
               </a:spcAft>
-              <a:defRPr sz="1200">
+              <a:defRPr sz="1200" b="0">
                 <a:solidFill>
                   <a:srgbClr val="1C2734"/>
                 </a:solidFill>
@@ -4878,7 +4963,522 @@
               </a:defRPr>
             </a:pPr>
             <a:r>
-              <a:t>Para el caso logístico, la decisión debe dejar claro qué comportamiento se protege, qué dependencias se aceptan y cómo se responderá ante cambios o fallos.</a:t>
+              <a:t>En equipos, aplicar el tema a la plataforma logística. Partir del caso: la plataforma logística debe recibir pedidos, asignar rutas y responder ante retrasos sin perder trazabilidad. Escribir el supuesto principal, proponer dos alternativas, elegir una y justificar la elección con tres criterios. Cerrar con un diagrama o fragmento de código que haga visible la decisión.</a:t>
+            </a:r>
+            <a:br/>
+            <a:br/>
+            <a:r>
+              <a:t>La evidencia mínima debe incluir: contexto del problema, decisión tomada, alternativa descartada, dos consecuencias esperadas y una forma de verificación. Guardarla en el repositorio dentro de la carpeta correspondiente a Actividad 1: diagnóstico y contexto arquitectónico.</a:t>
+            </a:r>
+          </a:p>
+          <a:p>
+            <a:pPr>
+              <a:spcAft>
+                <a:spcPts val="400"/>
+              </a:spcAft>
+              <a:defRPr sz="1300">
+                <a:solidFill>
+                  <a:srgbClr val="1C2734"/>
+                </a:solidFill>
+                <a:latin typeface="Aptos"/>
+              </a:defRPr>
+            </a:pPr>
+            <a:r>
+              <a:t>Evidencia: decisión, alternativa, trade-off y verificación.</a:t>
+            </a:r>
+          </a:p>
+        </p:txBody>
+      </p:sp>
+    </p:spTree>
+  </p:cSld>
+  <p:clrMapOvr>
+    <a:masterClrMapping/>
+  </p:clrMapOvr>
+</p:sld>
+</file>
+
+<file path=ppt/slides/slide4.xml><?xml version="1.0" encoding="utf-8"?>
+<p:sld xmlns:a="http://schemas.openxmlformats.org/drawingml/2006/main" xmlns:p="http://schemas.openxmlformats.org/presentationml/2006/main" xmlns:r="http://schemas.openxmlformats.org/officeDocument/2006/relationships">
+  <p:cSld>
+    <p:spTree>
+      <p:nvGrpSpPr>
+        <p:cNvPr id="1" name=""/>
+        <p:cNvGrpSpPr/>
+        <p:nvPr/>
+      </p:nvGrpSpPr>
+      <p:grpSpPr/>
+      <p:sp>
+        <p:nvSpPr>
+          <p:cNvPr id="2" name="Rectangle 1"/>
+          <p:cNvSpPr/>
+          <p:nvPr/>
+        </p:nvSpPr>
+        <p:spPr>
+          <a:xfrm>
+            <a:off x="0" y="0"/>
+            <a:ext cx="12191695" cy="6858000"/>
+          </a:xfrm>
+          <a:prstGeom prst="rect">
+            <a:avLst/>
+          </a:prstGeom>
+          <a:solidFill>
+            <a:srgbClr val="EFF3F7"/>
+          </a:solidFill>
+          <a:ln>
+            <a:noFill/>
+          </a:ln>
+        </p:spPr>
+        <p:style>
+          <a:lnRef idx="1">
+            <a:schemeClr val="accent1"/>
+          </a:lnRef>
+          <a:fillRef idx="3">
+            <a:schemeClr val="accent1"/>
+          </a:fillRef>
+          <a:effectRef idx="2">
+            <a:schemeClr val="accent1"/>
+          </a:effectRef>
+          <a:fontRef idx="minor">
+            <a:schemeClr val="lt1"/>
+          </a:fontRef>
+        </p:style>
+        <p:txBody>
+          <a:bodyPr rtlCol="0" anchor="ctr"/>
+          <a:lstStyle/>
+          <a:p>
+            <a:pPr algn="ctr"/>
+          </a:p>
+        </p:txBody>
+      </p:sp>
+      <p:sp>
+        <p:nvSpPr>
+          <p:cNvPr id="3" name="Rectangle 2"/>
+          <p:cNvSpPr/>
+          <p:nvPr/>
+        </p:nvSpPr>
+        <p:spPr>
+          <a:xfrm>
+            <a:off x="11850624" y="0"/>
+            <a:ext cx="338328" cy="6858000"/>
+          </a:xfrm>
+          <a:prstGeom prst="rect">
+            <a:avLst/>
+          </a:prstGeom>
+          <a:solidFill>
+            <a:srgbClr val="E0B24C"/>
+          </a:solidFill>
+          <a:ln>
+            <a:noFill/>
+          </a:ln>
+        </p:spPr>
+        <p:style>
+          <a:lnRef idx="1">
+            <a:schemeClr val="accent1"/>
+          </a:lnRef>
+          <a:fillRef idx="3">
+            <a:schemeClr val="accent1"/>
+          </a:fillRef>
+          <a:effectRef idx="2">
+            <a:schemeClr val="accent1"/>
+          </a:effectRef>
+          <a:fontRef idx="minor">
+            <a:schemeClr val="lt1"/>
+          </a:fontRef>
+        </p:style>
+        <p:txBody>
+          <a:bodyPr rtlCol="0" anchor="ctr"/>
+          <a:lstStyle/>
+          <a:p>
+            <a:pPr algn="ctr"/>
+          </a:p>
+        </p:txBody>
+      </p:sp>
+      <p:sp>
+        <p:nvSpPr>
+          <p:cNvPr id="4" name="Rectangle 3"/>
+          <p:cNvSpPr/>
+          <p:nvPr/>
+        </p:nvSpPr>
+        <p:spPr>
+          <a:xfrm>
+            <a:off x="0" y="0"/>
+            <a:ext cx="12191695" cy="987552"/>
+          </a:xfrm>
+          <a:prstGeom prst="rect">
+            <a:avLst/>
+          </a:prstGeom>
+          <a:solidFill>
+            <a:srgbClr val="09172A"/>
+          </a:solidFill>
+          <a:ln>
+            <a:noFill/>
+          </a:ln>
+        </p:spPr>
+        <p:style>
+          <a:lnRef idx="1">
+            <a:schemeClr val="accent1"/>
+          </a:lnRef>
+          <a:fillRef idx="3">
+            <a:schemeClr val="accent1"/>
+          </a:fillRef>
+          <a:effectRef idx="2">
+            <a:schemeClr val="accent1"/>
+          </a:effectRef>
+          <a:fontRef idx="minor">
+            <a:schemeClr val="lt1"/>
+          </a:fontRef>
+        </p:style>
+        <p:txBody>
+          <a:bodyPr rtlCol="0" anchor="ctr"/>
+          <a:lstStyle/>
+          <a:p>
+            <a:pPr algn="ctr"/>
+          </a:p>
+        </p:txBody>
+      </p:sp>
+      <p:sp>
+        <p:nvSpPr>
+          <p:cNvPr id="5" name="Rectangle 4"/>
+          <p:cNvSpPr/>
+          <p:nvPr/>
+        </p:nvSpPr>
+        <p:spPr>
+          <a:xfrm>
+            <a:off x="411480" y="210312"/>
+            <a:ext cx="73152" cy="475488"/>
+          </a:xfrm>
+          <a:prstGeom prst="rect">
+            <a:avLst/>
+          </a:prstGeom>
+          <a:solidFill>
+            <a:srgbClr val="E0B24C"/>
+          </a:solidFill>
+          <a:ln>
+            <a:noFill/>
+          </a:ln>
+        </p:spPr>
+        <p:style>
+          <a:lnRef idx="1">
+            <a:schemeClr val="accent1"/>
+          </a:lnRef>
+          <a:fillRef idx="3">
+            <a:schemeClr val="accent1"/>
+          </a:fillRef>
+          <a:effectRef idx="2">
+            <a:schemeClr val="accent1"/>
+          </a:effectRef>
+          <a:fontRef idx="minor">
+            <a:schemeClr val="lt1"/>
+          </a:fontRef>
+        </p:style>
+        <p:txBody>
+          <a:bodyPr rtlCol="0" anchor="ctr"/>
+          <a:lstStyle/>
+          <a:p>
+            <a:pPr algn="ctr"/>
+          </a:p>
+        </p:txBody>
+      </p:sp>
+      <p:sp>
+        <p:nvSpPr>
+          <p:cNvPr id="6" name="TextBox 5"/>
+          <p:cNvSpPr txBox="1"/>
+          <p:nvPr/>
+        </p:nvSpPr>
+        <p:spPr>
+          <a:xfrm>
+            <a:off x="640080" y="128016"/>
+            <a:ext cx="10058400" cy="429768"/>
+          </a:xfrm>
+          <a:prstGeom prst="rect">
+            <a:avLst/>
+          </a:prstGeom>
+          <a:noFill/>
+        </p:spPr>
+        <p:txBody>
+          <a:bodyPr wrap="square" lIns="0" rIns="0">
+            <a:spAutoFit/>
+          </a:bodyPr>
+          <a:lstStyle/>
+          <a:p>
+            <a:pPr>
+              <a:defRPr b="1" sz="1900">
+                <a:solidFill>
+                  <a:srgbClr val="FFFFFF"/>
+                </a:solidFill>
+                <a:latin typeface="Aptos Display"/>
+              </a:defRPr>
+            </a:pPr>
+            <a:r>
+              <a:t>Video 1 — Video 1: Decisiones de arquitectura y consecuencias reales</a:t>
+            </a:r>
+          </a:p>
+        </p:txBody>
+      </p:sp>
+      <p:sp>
+        <p:nvSpPr>
+          <p:cNvPr id="7" name="TextBox 6"/>
+          <p:cNvSpPr txBox="1"/>
+          <p:nvPr/>
+        </p:nvSpPr>
+        <p:spPr>
+          <a:xfrm>
+            <a:off x="658368" y="658368"/>
+            <a:ext cx="7772400" cy="201168"/>
+          </a:xfrm>
+          <a:prstGeom prst="rect">
+            <a:avLst/>
+          </a:prstGeom>
+          <a:noFill/>
+        </p:spPr>
+        <p:txBody>
+          <a:bodyPr wrap="none" lIns="0" rIns="0">
+            <a:spAutoFit/>
+          </a:bodyPr>
+          <a:lstStyle/>
+          <a:p>
+            <a:pPr>
+              <a:defRPr sz="800" b="1">
+                <a:solidFill>
+                  <a:srgbClr val="B7C7D5"/>
+                </a:solidFill>
+                <a:latin typeface="Aptos"/>
+              </a:defRPr>
+            </a:pPr>
+            <a:r>
+              <a:t>Conclusión y reflexión</a:t>
+            </a:r>
+          </a:p>
+        </p:txBody>
+      </p:sp>
+      <p:sp>
+        <p:nvSpPr>
+          <p:cNvPr id="8" name="TextBox 7"/>
+          <p:cNvSpPr txBox="1"/>
+          <p:nvPr/>
+        </p:nvSpPr>
+        <p:spPr>
+          <a:xfrm>
+            <a:off x="10561320" y="256032"/>
+            <a:ext cx="685800" cy="365760"/>
+          </a:xfrm>
+          <a:prstGeom prst="rect">
+            <a:avLst/>
+          </a:prstGeom>
+          <a:noFill/>
+        </p:spPr>
+        <p:txBody>
+          <a:bodyPr wrap="none">
+            <a:spAutoFit/>
+          </a:bodyPr>
+          <a:lstStyle/>
+          <a:p>
+            <a:pPr algn="r">
+              <a:defRPr sz="2300" b="1">
+                <a:solidFill>
+                  <a:srgbClr val="E0B24C"/>
+                </a:solidFill>
+                <a:latin typeface="Aptos Display"/>
+              </a:defRPr>
+            </a:pPr>
+            <a:r>
+              <a:t>01</a:t>
+            </a:r>
+          </a:p>
+        </p:txBody>
+      </p:sp>
+      <p:sp>
+        <p:nvSpPr>
+          <p:cNvPr id="9" name="Rectangle 8"/>
+          <p:cNvSpPr/>
+          <p:nvPr/>
+        </p:nvSpPr>
+        <p:spPr>
+          <a:xfrm>
+            <a:off x="502920" y="6473952"/>
+            <a:ext cx="11018520" cy="13716"/>
+          </a:xfrm>
+          <a:prstGeom prst="rect">
+            <a:avLst/>
+          </a:prstGeom>
+          <a:solidFill>
+            <a:srgbClr val="D2DBE3"/>
+          </a:solidFill>
+          <a:ln>
+            <a:noFill/>
+          </a:ln>
+        </p:spPr>
+        <p:style>
+          <a:lnRef idx="1">
+            <a:schemeClr val="accent1"/>
+          </a:lnRef>
+          <a:fillRef idx="3">
+            <a:schemeClr val="accent1"/>
+          </a:fillRef>
+          <a:effectRef idx="2">
+            <a:schemeClr val="accent1"/>
+          </a:effectRef>
+          <a:fontRef idx="minor">
+            <a:schemeClr val="lt1"/>
+          </a:fontRef>
+        </p:style>
+        <p:txBody>
+          <a:bodyPr rtlCol="0" anchor="ctr"/>
+          <a:lstStyle/>
+          <a:p>
+            <a:pPr algn="ctr"/>
+          </a:p>
+        </p:txBody>
+      </p:sp>
+      <p:sp>
+        <p:nvSpPr>
+          <p:cNvPr id="10" name="TextBox 9"/>
+          <p:cNvSpPr txBox="1"/>
+          <p:nvPr/>
+        </p:nvSpPr>
+        <p:spPr>
+          <a:xfrm>
+            <a:off x="548640" y="6528816"/>
+            <a:ext cx="5486400" cy="182880"/>
+          </a:xfrm>
+          <a:prstGeom prst="rect">
+            <a:avLst/>
+          </a:prstGeom>
+          <a:noFill/>
+        </p:spPr>
+        <p:txBody>
+          <a:bodyPr wrap="none" lIns="0" rIns="0">
+            <a:spAutoFit/>
+          </a:bodyPr>
+          <a:lstStyle/>
+          <a:p>
+            <a:pPr>
+              <a:defRPr sz="700" b="1">
+                <a:solidFill>
+                  <a:srgbClr val="5B6977"/>
+                </a:solidFill>
+                <a:latin typeface="Aptos"/>
+              </a:defRPr>
+            </a:pPr>
+            <a:r>
+              <a:t>ARQUITECTURA DE SOFTWARE  /  MATERIAL DE CLASE</a:t>
+            </a:r>
+          </a:p>
+        </p:txBody>
+      </p:sp>
+      <p:sp>
+        <p:nvSpPr>
+          <p:cNvPr id="11" name="TextBox 10"/>
+          <p:cNvSpPr txBox="1"/>
+          <p:nvPr/>
+        </p:nvSpPr>
+        <p:spPr>
+          <a:xfrm>
+            <a:off x="9784080" y="6492240"/>
+            <a:ext cx="1554480" cy="228600"/>
+          </a:xfrm>
+          <a:prstGeom prst="rect">
+            <a:avLst/>
+          </a:prstGeom>
+          <a:noFill/>
+        </p:spPr>
+        <p:txBody>
+          <a:bodyPr wrap="none" lIns="0" rIns="0">
+            <a:spAutoFit/>
+          </a:bodyPr>
+          <a:lstStyle/>
+          <a:p>
+            <a:pPr algn="r">
+              <a:defRPr sz="800" b="1">
+                <a:solidFill>
+                  <a:srgbClr val="09172A"/>
+                </a:solidFill>
+                <a:latin typeface="Aptos"/>
+              </a:defRPr>
+            </a:pPr>
+            <a:r>
+              <a:t>VIDEO 01  /  04 / 04</a:t>
+            </a:r>
+          </a:p>
+        </p:txBody>
+      </p:sp>
+      <p:sp>
+        <p:nvSpPr>
+          <p:cNvPr id="12" name="Rounded Rectangle 11"/>
+          <p:cNvSpPr/>
+          <p:nvPr/>
+        </p:nvSpPr>
+        <p:spPr>
+          <a:xfrm>
+            <a:off x="640080" y="1417320"/>
+            <a:ext cx="5577840" cy="4434840"/>
+          </a:xfrm>
+          <a:prstGeom prst="roundRect">
+            <a:avLst/>
+          </a:prstGeom>
+          <a:solidFill>
+            <a:srgbClr val="FFFFFF"/>
+          </a:solidFill>
+          <a:ln w="1">
+            <a:solidFill>
+              <a:srgbClr val="D2DBE3"/>
+            </a:solidFill>
+          </a:ln>
+        </p:spPr>
+        <p:style>
+          <a:lnRef idx="1">
+            <a:schemeClr val="accent1"/>
+          </a:lnRef>
+          <a:fillRef idx="3">
+            <a:schemeClr val="accent1"/>
+          </a:fillRef>
+          <a:effectRef idx="2">
+            <a:schemeClr val="accent1"/>
+          </a:effectRef>
+          <a:fontRef idx="minor">
+            <a:schemeClr val="lt1"/>
+          </a:fontRef>
+        </p:style>
+        <p:txBody>
+          <a:bodyPr rtlCol="0" anchor="ctr"/>
+          <a:lstStyle/>
+          <a:p>
+            <a:pPr algn="ctr"/>
+          </a:p>
+        </p:txBody>
+      </p:sp>
+      <p:sp>
+        <p:nvSpPr>
+          <p:cNvPr id="13" name="TextBox 12"/>
+          <p:cNvSpPr txBox="1"/>
+          <p:nvPr/>
+        </p:nvSpPr>
+        <p:spPr>
+          <a:xfrm>
+            <a:off x="804671" y="1527048"/>
+            <a:ext cx="5257800" cy="4297679"/>
+          </a:xfrm>
+          <a:prstGeom prst="rect">
+            <a:avLst/>
+          </a:prstGeom>
+          <a:noFill/>
+        </p:spPr>
+        <p:txBody>
+          <a:bodyPr wrap="square" lIns="36576" rIns="36576" tIns="18288" anchor="t">
+            <a:spAutoFit/>
+          </a:bodyPr>
+          <a:lstStyle/>
+          <a:p>
+            <a:pPr>
+              <a:defRPr b="1" sz="1500">
+                <a:solidFill>
+                  <a:srgbClr val="239391"/>
+                </a:solidFill>
+                <a:latin typeface="Aptos Display"/>
+              </a:defRPr>
+            </a:pPr>
+            <a:r>
+              <a:t>Conclusión</a:t>
             </a:r>
           </a:p>
         </p:txBody>

</xml_diff>